<commit_message>
Bend deck: slide 4 uses the real 5NK0050 modulating cross-section
S 35 / gap 4.15 / Wg 50 um, 2 um gold on the 275 nm slab of the C-band
550 nm TFLN, ribs in the gaps. The previous figure used the FEM notebook's
COMSOL cross-section (9.1 um gold), which is not the device line.

Co-Authored-By: Claude Opus 5.5 <noreply@anthropic.com>
Claude-Session: https://claude.ai/code/session_01PF7RKNjFsSkyjm1syGCUrV
</commit_message>
<xml_diff>
--- a/docs/Bend_line_design.pptx
+++ b/docs/Bend_line_design.pptx
@@ -2535,7 +2535,7 @@
           <a:lstStyle/>
           <a:p>
             <a:r>
-              <a:t>Left: the modulating section as in the FEM notebook (thick 9 um gold on the LN thin film, ribs in the gaps, SiO2 caps), drawn here as an illustration of a modulating cross-section; the electrical numbers in the table are the measured 5NK0050 line, which is the line of the device in this talk. Right: the bend. Where the electrode turns, the waveguides are routed differently: there are no LN ribs under the bend, the gold is 2 um thick and sits on 3.6 um of SiO2 above a 275 nm LN slab. With almost no LN in the field, the microwave index drops from about 2.29 to 1.73: the RF is faster than the light (n_g 2.27). So the bend is a line of its own: its length decides how long the RF takes to reach the next section, and its impedance decides whether there are reflections at both ends. The inverse design later chooses S, W, Wg so that |Zc| equals the line's.</a:t>
+              <a:t>Left: the modulating section of the 5NK0050 device, C-band 550 nm TFLN etched by 275 nm (275 nm slab): S 35 um, gap 4.15 um, Wg 50 um, 2 um gold sitting on the LN slab, with the waveguide ribs in the gaps. The table gives the measured 5NK0050 line. Right: the bend. Where the electrode turns, the waveguides are routed elsewhere: no LN ribs under the bend, the gold is still 2 um thick (same metal layer, no new mask) but sits on 3.6 um of SiO2 above the 275 nm LN slab. The zooms show the right-hand gap at true scale. With almost no LN in the field, the microwave index drops from about 2.29 to 1.73: the RF is faster than the light (n_g 2.27). So the bend is a line of its own: its length decides how long the RF takes to reach the next section, and its impedance decides whether there are reflections at both ends. The inverse design later chooses S, W, Wg so that |Zc| equals the line's.</a:t>
             </a:r>
           </a:p>
         </p:txBody>
@@ -24393,7 +24393,7 @@
                 </a:solidFill>
                 <a:latin typeface="Arial"/>
               </a:rPr>
-              <a:t>Ribs removed, thinner gold, electrodes on 3.6 µm SiO₂: a different line</a:t>
+              <a:t>Same 2 µm gold; no ribs, electrodes on 3.6 µm SiO₂ instead of the LN slab: a different line</a:t>
             </a:r>
           </a:p>
         </p:txBody>
@@ -24414,8 +24414,8 @@
         </p:blipFill>
         <p:spPr>
           <a:xfrm>
-            <a:off x="1040033" y="1371600"/>
-            <a:ext cx="10111628" cy="3154680"/>
+            <a:off x="1053566" y="1371600"/>
+            <a:ext cx="10084561" cy="3154680"/>
           </a:xfrm>
           <a:prstGeom prst="rect">
             <a:avLst/>

</xml_diff>

<commit_message>
Bend deck slide 4: true-scale cross-sections, 1 um rib, 2 x 1.4 um cap
Single-slide file docs/Bend_line_design_slide4.pptx; the full deck carries
the same slide.

Co-Authored-By: Claude Opus 5.5 <noreply@anthropic.com>
Claude-Session: https://claude.ai/code/session_01PF7RKNjFsSkyjm1syGCUrV
</commit_message>
<xml_diff>
--- a/docs/Bend_line_design.pptx
+++ b/docs/Bend_line_design.pptx
@@ -24414,8 +24414,8 @@
         </p:blipFill>
         <p:spPr>
           <a:xfrm>
-            <a:off x="1053566" y="1371600"/>
-            <a:ext cx="10084561" cy="3154680"/>
+            <a:off x="1796096" y="1371600"/>
+            <a:ext cx="8599502" cy="3154680"/>
           </a:xfrm>
           <a:prstGeom prst="rect">
             <a:avLst/>

</xml_diff>